<commit_message>
Updated wording on the slides
</commit_message>
<xml_diff>
--- a/Slides.pptx
+++ b/Slides.pptx
@@ -6193,7 +6193,7 @@
                 <a:cs typeface="Calibri"/>
                 <a:sym typeface="Calibri"/>
               </a:rPr>
-              <a:t>lwurtzel.github.io/Discerning-the-Synthetic</a:t>
+              <a:t>github.com/LWurtzel/Discerning-the-Synthetic</a:t>
             </a:r>
             <a:endParaRPr b="0" i="0" sz="1650" u="none" cap="none" strike="noStrike">
               <a:solidFill>
@@ -6256,7 +6256,7 @@
                 <a:cs typeface="Calibri"/>
                 <a:sym typeface="Calibri"/>
               </a:rPr>
-              <a:t>Same twenty images — can you beat the model?</a:t>
+              <a:t>Same ten images — can you beat the model?</a:t>
             </a:r>
             <a:endParaRPr b="0" i="0" sz="1600" u="none" cap="none" strike="noStrike">
               <a:solidFill>

</xml_diff>